<commit_message>
slides(2-1-Agents): slide 20 activity prompts → verbatim Google Form parity
The five activity prompts on slide 20 now match the live Google Form
character-for-character, so a team reading the slide sees the same
wording as the form it submits to.

ENGINEERING ENVIRONMENT keeps its first prompt and replaces the other
two. AGENT HARNESS drops to two prompts. That box held three, so its
height shrinks 1.62in -> 1.52in to fit the new content instead of
centring two questions in an oversized panel; x, width, fill, border
and type are untouched, and the gap to the bottom instruction bar
widens from 0.07in to 0.17in.

The three ENGINEERING ENVIRONMENT prompts gain 16pt of space-after so
they read as three prompts rather than one block. Font size unchanged
(inherited 18pt) — breathing room, not bigger type.

Only ppt/slides/slide20.xml differs; the other 178 OPC parts hash
identical to HEAD.

Co-Authored-By: Claude Opus 5 <noreply@anthropic.com>
</commit_message>
<xml_diff>
--- a/course/lectures/act-2-delegation-and-control/01-delegation/2-1-Agents.pptx
+++ b/course/lectures/act-2-delegation-and-control/01-delegation/2-1-Agents.pptx
@@ -14120,7 +14120,7 @@
           <a:p>
             <a:pPr algn="l">
               <a:spcAft>
-                <a:spcPts val="400"/>
+                <a:spcPts val="1600"/>
               </a:spcAft>
             </a:pPr>
             <a:r>
@@ -14135,7 +14135,7 @@
           <a:p>
             <a:pPr algn="l">
               <a:spcAft>
-                <a:spcPts val="400"/>
+                <a:spcPts val="1600"/>
               </a:spcAft>
             </a:pPr>
             <a:r>
@@ -14144,7 +14144,7 @@
                   <a:srgbClr val="5C4826"/>
                 </a:solidFill>
               </a:rPr>
-              <a:t>What engineering knowledge should be available to the agent?</a:t>
+              <a:t>How will you scope the knowledge given to the agent?</a:t>
             </a:r>
           </a:p>
           <a:p>
@@ -14159,7 +14159,7 @@
                   <a:srgbClr val="5C4826"/>
                 </a:solidFill>
               </a:rPr>
-              <a:t>What should be represented explicitly rather than repeatedly reconstructed?</a:t>
+              <a:t>How will those artifacts and limits bound the problem?</a:t>
             </a:r>
           </a:p>
         </p:txBody>
@@ -14211,7 +14211,7 @@
         <p:spPr>
           <a:xfrm>
             <a:off x="365760" y="4306824"/>
-            <a:ext cx="6080760" cy="1481328"/>
+            <a:ext cx="6080760" cy="1389888"/>
           </a:xfrm>
           <a:prstGeom prst="rect">
             <a:avLst/>
@@ -14245,7 +14245,7 @@
           <a:p>
             <a:pPr algn="l">
               <a:spcAft>
-                <a:spcPts val="400"/>
+                <a:spcPts val="1600"/>
               </a:spcAft>
             </a:pPr>
             <a:r>
@@ -14254,22 +14254,7 @@
                   <a:srgbClr val="5C4826"/>
                 </a:solidFill>
               </a:rPr>
-              <a:t>What tools or services will implementation require?</a:t>
-            </a:r>
-          </a:p>
-          <a:p>
-            <a:pPr algn="l">
-              <a:spcAft>
-                <a:spcPts val="400"/>
-              </a:spcAft>
-            </a:pPr>
-            <a:r>
-              <a:rPr dirty="0">
-                <a:solidFill>
-                  <a:srgbClr val="5C4826"/>
-                </a:solidFill>
-              </a:rPr>
-              <a:t>How will relevant context and state reach the agent?</a:t>
+              <a:t>Which specific tools will the agents need for your project implementation?</a:t>
             </a:r>
           </a:p>
           <a:p>
@@ -14284,7 +14269,7 @@
                   <a:srgbClr val="5C4826"/>
                 </a:solidFill>
               </a:rPr>
-              <a:t>Identify one useful external capability and how the harness will expose it.</a:t>
+              <a:t>Describe one MCP interface that abstracts access to the tools.</a:t>
             </a:r>
           </a:p>
         </p:txBody>

</xml_diff>